<commit_message>
Add more final exams question
</commit_message>
<xml_diff>
--- a/SBS/1/Ondřej Švorc - 1.pptx
+++ b/SBS/1/Ondřej Švorc - 1.pptx
@@ -4407,13 +4407,13 @@
   <p:clrMapOvr>
     <a:masterClrMapping/>
   </p:clrMapOvr>
-  <mc:AlternateContent xmlns:mc="http://schemas.openxmlformats.org/markup-compatibility/2006">
-    <mc:Choice xmlns:p14="http://schemas.microsoft.com/office/powerpoint/2010/main" Requires="p14">
+  <mc:AlternateContent xmlns:mc="http://schemas.openxmlformats.org/markup-compatibility/2006" xmlns:p14="http://schemas.microsoft.com/office/powerpoint/2010/main">
+    <mc:Choice Requires="p14">
       <p:transition p14:dur="250">
         <p:fade/>
       </p:transition>
     </mc:Choice>
-    <mc:Fallback>
+    <mc:Fallback xmlns="">
       <p:transition>
         <p:fade/>
       </p:transition>
@@ -4471,52 +4471,6 @@
               </a:rPr>
               <a:t>Děkuji za pozornost</a:t>
             </a:r>
-          </a:p>
-        </p:txBody>
-      </p:sp>
-      <p:sp>
-        <p:nvSpPr>
-          <p:cNvPr id="3" name="Podnadpis 2">
-            <a:extLst>
-              <a:ext uri="{FF2B5EF4-FFF2-40B4-BE49-F238E27FC236}">
-                <a16:creationId xmlns:a16="http://schemas.microsoft.com/office/drawing/2014/main" id="{530854EB-EDDA-FFA7-9996-854BF6244753}"/>
-              </a:ext>
-            </a:extLst>
-          </p:cNvPr>
-          <p:cNvSpPr>
-            <a:spLocks noGrp="1"/>
-          </p:cNvSpPr>
-          <p:nvPr>
-            <p:ph type="subTitle" idx="1"/>
-          </p:nvPr>
-        </p:nvSpPr>
-        <p:spPr>
-          <a:xfrm>
-            <a:off x="1524000" y="3447786"/>
-            <a:ext cx="9144000" cy="1655762"/>
-          </a:xfrm>
-        </p:spPr>
-        <p:txBody>
-          <a:bodyPr>
-            <a:normAutofit/>
-          </a:bodyPr>
-          <a:lstStyle/>
-          <a:p>
-            <a:pPr algn="l"/>
-            <a:r>
-              <a:rPr lang="cs-CZ" sz="2580" dirty="0">
-                <a:solidFill>
-                  <a:srgbClr val="002060"/>
-                </a:solidFill>
-                <a:hlinkClick r:id="rId2"/>
-              </a:rPr>
-              <a:t>github.com/ondrejsvorc/UJEP/blob/main/SBS/1/1.md</a:t>
-            </a:r>
-            <a:endParaRPr lang="en-US" sz="2580" dirty="0">
-              <a:solidFill>
-                <a:srgbClr val="002060"/>
-              </a:solidFill>
-            </a:endParaRPr>
           </a:p>
         </p:txBody>
       </p:sp>
@@ -5100,13 +5054,13 @@
   <p:clrMapOvr>
     <a:masterClrMapping/>
   </p:clrMapOvr>
-  <mc:AlternateContent xmlns:mc="http://schemas.openxmlformats.org/markup-compatibility/2006">
-    <mc:Choice xmlns:p14="http://schemas.microsoft.com/office/powerpoint/2010/main" Requires="p14">
+  <mc:AlternateContent xmlns:mc="http://schemas.openxmlformats.org/markup-compatibility/2006" xmlns:p14="http://schemas.microsoft.com/office/powerpoint/2010/main">
+    <mc:Choice Requires="p14">
       <p:transition p14:dur="250">
         <p:fade/>
       </p:transition>
     </mc:Choice>
-    <mc:Fallback>
+    <mc:Fallback xmlns="">
       <p:transition>
         <p:fade/>
       </p:transition>
@@ -5288,13 +5242,13 @@
   <p:clrMapOvr>
     <a:masterClrMapping/>
   </p:clrMapOvr>
-  <mc:AlternateContent xmlns:mc="http://schemas.openxmlformats.org/markup-compatibility/2006">
-    <mc:Choice xmlns:p14="http://schemas.microsoft.com/office/powerpoint/2010/main" Requires="p14">
+  <mc:AlternateContent xmlns:mc="http://schemas.openxmlformats.org/markup-compatibility/2006" xmlns:p14="http://schemas.microsoft.com/office/powerpoint/2010/main">
+    <mc:Choice Requires="p14">
       <p:transition p14:dur="250">
         <p:fade/>
       </p:transition>
     </mc:Choice>
-    <mc:Fallback>
+    <mc:Fallback xmlns="">
       <p:transition>
         <p:fade/>
       </p:transition>
@@ -5607,13 +5561,13 @@
   <p:clrMapOvr>
     <a:masterClrMapping/>
   </p:clrMapOvr>
-  <mc:AlternateContent xmlns:mc="http://schemas.openxmlformats.org/markup-compatibility/2006">
-    <mc:Choice xmlns:p14="http://schemas.microsoft.com/office/powerpoint/2010/main" Requires="p14">
+  <mc:AlternateContent xmlns:mc="http://schemas.openxmlformats.org/markup-compatibility/2006" xmlns:p14="http://schemas.microsoft.com/office/powerpoint/2010/main">
+    <mc:Choice Requires="p14">
       <p:transition p14:dur="250">
         <p:fade/>
       </p:transition>
     </mc:Choice>
-    <mc:Fallback>
+    <mc:Fallback xmlns="">
       <p:transition>
         <p:fade/>
       </p:transition>
@@ -5901,13 +5855,13 @@
   <p:clrMapOvr>
     <a:masterClrMapping/>
   </p:clrMapOvr>
-  <mc:AlternateContent xmlns:mc="http://schemas.openxmlformats.org/markup-compatibility/2006">
-    <mc:Choice xmlns:p14="http://schemas.microsoft.com/office/powerpoint/2010/main" Requires="p14">
+  <mc:AlternateContent xmlns:mc="http://schemas.openxmlformats.org/markup-compatibility/2006" xmlns:p14="http://schemas.microsoft.com/office/powerpoint/2010/main">
+    <mc:Choice Requires="p14">
       <p:transition p14:dur="250">
         <p:fade/>
       </p:transition>
     </mc:Choice>
-    <mc:Fallback>
+    <mc:Fallback xmlns="">
       <p:transition>
         <p:fade/>
       </p:transition>
@@ -6227,13 +6181,13 @@
   <p:clrMapOvr>
     <a:masterClrMapping/>
   </p:clrMapOvr>
-  <mc:AlternateContent xmlns:mc="http://schemas.openxmlformats.org/markup-compatibility/2006">
-    <mc:Choice xmlns:p14="http://schemas.microsoft.com/office/powerpoint/2010/main" Requires="p14">
+  <mc:AlternateContent xmlns:mc="http://schemas.openxmlformats.org/markup-compatibility/2006" xmlns:p14="http://schemas.microsoft.com/office/powerpoint/2010/main">
+    <mc:Choice Requires="p14">
       <p:transition p14:dur="250">
         <p:fade/>
       </p:transition>
     </mc:Choice>
-    <mc:Fallback>
+    <mc:Fallback xmlns="">
       <p:transition>
         <p:fade/>
       </p:transition>
@@ -6539,13 +6493,13 @@
   <p:clrMapOvr>
     <a:masterClrMapping/>
   </p:clrMapOvr>
-  <mc:AlternateContent xmlns:mc="http://schemas.openxmlformats.org/markup-compatibility/2006">
-    <mc:Choice xmlns:p14="http://schemas.microsoft.com/office/powerpoint/2010/main" Requires="p14">
+  <mc:AlternateContent xmlns:mc="http://schemas.openxmlformats.org/markup-compatibility/2006" xmlns:p14="http://schemas.microsoft.com/office/powerpoint/2010/main">
+    <mc:Choice Requires="p14">
       <p:transition p14:dur="250">
         <p:fade/>
       </p:transition>
     </mc:Choice>
-    <mc:Fallback>
+    <mc:Fallback xmlns="">
       <p:transition>
         <p:fade/>
       </p:transition>
@@ -6845,13 +6799,13 @@
   <p:clrMapOvr>
     <a:masterClrMapping/>
   </p:clrMapOvr>
-  <mc:AlternateContent xmlns:mc="http://schemas.openxmlformats.org/markup-compatibility/2006">
-    <mc:Choice xmlns:p14="http://schemas.microsoft.com/office/powerpoint/2010/main" Requires="p14">
+  <mc:AlternateContent xmlns:mc="http://schemas.openxmlformats.org/markup-compatibility/2006" xmlns:p14="http://schemas.microsoft.com/office/powerpoint/2010/main">
+    <mc:Choice Requires="p14">
       <p:transition p14:dur="250">
         <p:fade/>
       </p:transition>
     </mc:Choice>
-    <mc:Fallback>
+    <mc:Fallback xmlns="">
       <p:transition>
         <p:fade/>
       </p:transition>

</xml_diff>